<commit_message>
Fix accuracy errors from course audit
Co-Authored-By: Claude Opus 5.5 <noreply@anthropic.com>
Claude-Session: https://claude.ai/code/session_01XjeeUvVwCQfhSSHE1beg7G
</commit_message>
<xml_diff>
--- a/Lesson 2/OrangeEnglish_Lesson2_VocabularyForTrends.pptx
+++ b/Lesson 2/OrangeEnglish_Lesson2_VocabularyForTrends.pptx
@@ -2699,7 +2699,7 @@
                 <a:ea typeface="Inter" pitchFamily="34" charset="-122"/>
                 <a:cs typeface="Inter" pitchFamily="34" charset="-120"/>
               </a:rPr>
-              <a:t>Lesson 2 of 6 · IELTS Writing Task 1 · orangeenglish.nl</a:t>
+              <a:t>Lesson 2 of 8 · IELTS Writing Task 1 · orangeenglish.nl</a:t>
             </a:r>
             <a:endParaRPr lang="en-US" sz="1800" dirty="0"/>
           </a:p>
@@ -3429,7 +3429,7 @@
                 <a:ea typeface="Inter" pitchFamily="34" charset="-122"/>
                 <a:cs typeface="Inter" pitchFamily="34" charset="-120"/>
               </a:rPr>
-              <a:t>Lesson 2 of 6 · IELTS Writing Task 1 · orangeenglish.nl</a:t>
+              <a:t>Lesson 2 of 8 · IELTS Writing Task 1 · orangeenglish.nl</a:t>
             </a:r>
             <a:endParaRPr lang="en-US" sz="1800" dirty="0"/>
           </a:p>
@@ -4491,7 +4491,7 @@
                 <a:ea typeface="Inter" pitchFamily="34" charset="-122"/>
                 <a:cs typeface="Inter" pitchFamily="34" charset="-120"/>
               </a:rPr>
-              <a:t>Lesson 2 of 6 · IELTS Writing Task 1 · orangeenglish.nl</a:t>
+              <a:t>Lesson 2 of 8 · IELTS Writing Task 1 · orangeenglish.nl</a:t>
             </a:r>
             <a:endParaRPr lang="en-US" sz="1800" dirty="0"/>
           </a:p>
@@ -5553,7 +5553,7 @@
                 <a:ea typeface="Inter" pitchFamily="34" charset="-122"/>
                 <a:cs typeface="Inter" pitchFamily="34" charset="-120"/>
               </a:rPr>
-              <a:t>Lesson 2 of 6 · IELTS Writing Task 1 · orangeenglish.nl</a:t>
+              <a:t>Lesson 2 of 8 · IELTS Writing Task 1 · orangeenglish.nl</a:t>
             </a:r>
             <a:endParaRPr lang="en-US" sz="1800" dirty="0"/>
           </a:p>
@@ -6361,7 +6361,7 @@
                 <a:ea typeface="Inter" pitchFamily="34" charset="-122"/>
                 <a:cs typeface="Inter" pitchFamily="34" charset="-120"/>
               </a:rPr>
-              <a:t>Lesson 2 of 6 · IELTS Writing Task 1 · orangeenglish.nl</a:t>
+              <a:t>Lesson 2 of 8 · IELTS Writing Task 1 · orangeenglish.nl</a:t>
             </a:r>
             <a:endParaRPr lang="en-US" sz="1800" dirty="0"/>
           </a:p>
@@ -7680,7 +7680,7 @@
                 <a:ea typeface="Inter" pitchFamily="34" charset="-122"/>
                 <a:cs typeface="Inter" pitchFamily="34" charset="-120"/>
               </a:rPr>
-              <a:t>Lesson 2 of 6 · IELTS Writing Task 1 · orangeenglish.nl</a:t>
+              <a:t>Lesson 2 of 8 · IELTS Writing Task 1 · orangeenglish.nl</a:t>
             </a:r>
             <a:endParaRPr lang="en-US" sz="1800" dirty="0"/>
           </a:p>
@@ -8537,7 +8537,7 @@
                 <a:ea typeface="Inter" pitchFamily="34" charset="-122"/>
                 <a:cs typeface="Inter" pitchFamily="34" charset="-120"/>
               </a:rPr>
-              <a:t>Lesson 2 of 6 · IELTS Writing Task 1 · orangeenglish.nl</a:t>
+              <a:t>Lesson 2 of 8 · IELTS Writing Task 1 · orangeenglish.nl</a:t>
             </a:r>
             <a:endParaRPr lang="en-US" sz="1800" dirty="0"/>
           </a:p>
@@ -9787,7 +9787,7 @@
                 <a:ea typeface="Inter" pitchFamily="34" charset="-122"/>
                 <a:cs typeface="Inter" pitchFamily="34" charset="-120"/>
               </a:rPr>
-              <a:t>Lesson 2 of 6 · IELTS Writing Task 1 · orangeenglish.nl</a:t>
+              <a:t>Lesson 2 of 8 · IELTS Writing Task 1 · orangeenglish.nl</a:t>
             </a:r>
             <a:endParaRPr lang="en-US" sz="1800" dirty="0"/>
           </a:p>
@@ -11144,7 +11144,7 @@
                 <a:ea typeface="Inter" pitchFamily="34" charset="-122"/>
                 <a:cs typeface="Inter" pitchFamily="34" charset="-120"/>
               </a:rPr>
-              <a:t>Lesson 2 of 6 · IELTS Writing Task 1 · orangeenglish.nl</a:t>
+              <a:t>Lesson 2 of 8 · IELTS Writing Task 1 · orangeenglish.nl</a:t>
             </a:r>
             <a:endParaRPr lang="en-US" sz="1800" dirty="0"/>
           </a:p>

</xml_diff>